<commit_message>
feat(slides C4/C6/C8/C10): rediseno linea visual + datos con fuentes reales (3 variantes c/u)
Co-Authored-By: Claude Opus 4.8 <noreply@anthropic.com>
</commit_message>
<xml_diff>
--- a/clase_06_ml_modelos_predictivos/slides/slides_clase06_avanzado_enriquecido.pptx
+++ b/clase_06_ml_modelos_predictivos/slides/slides_clase06_avanzado_enriquecido.pptx
@@ -11,14 +11,12 @@
     <p:sldId id="259" r:id="rId10"/>
     <p:sldId id="260" r:id="rId11"/>
     <p:sldId id="261" r:id="rId12"/>
+    <p:sldId id="262" r:id="rId13"/>
     <p:sldId id="263" r:id="rId14"/>
     <p:sldId id="264" r:id="rId15"/>
     <p:sldId id="265" r:id="rId16"/>
-    <p:sldId id="266" r:id="rId17"/>
-    <p:sldId id="267" r:id="rId18"/>
-    <p:sldId id="262" r:id="rId13"/>
   </p:sldIdLst>
-  <p:sldSz cx="12191695" cy="6858000" type="screen4x3"/>
+  <p:sldSz cx="12192000" cy="6858000" type="screen4x3"/>
   <p:notesSz cx="6858000" cy="9144000"/>
   <p:defaultTextStyle>
     <a:defPPr>
@@ -3101,14 +3099,14 @@
       <p:grpSpPr/>
       <p:pic>
         <p:nvPicPr>
-          <p:cNvPr id="8" name="Picture 7" descr="cover_bg.png"/>
+          <p:cNvPr id="2" name="Picture 1" descr="title_bg.png"/>
           <p:cNvPicPr>
             <a:picLocks noChangeAspect="1"/>
           </p:cNvPicPr>
           <p:nvPr/>
         </p:nvPicPr>
         <p:blipFill>
-          <a:blip r:embed="rId3"/>
+          <a:blip r:embed="rId2"/>
           <a:stretch>
             <a:fillRect/>
           </a:stretch>
@@ -3116,7 +3114,7 @@
         <p:spPr>
           <a:xfrm>
             <a:off x="0" y="0"/>
-            <a:ext cx="12191695" cy="6858000"/>
+            <a:ext cx="12192000" cy="6858000"/>
           </a:xfrm>
           <a:prstGeom prst="rect">
             <a:avLst/>
@@ -3131,8 +3129,8 @@
         </p:nvSpPr>
         <p:spPr>
           <a:xfrm>
-            <a:off x="566928" y="4041648"/>
-            <a:ext cx="8229600" cy="411480"/>
+            <a:off x="566928" y="2880360"/>
+            <a:ext cx="5486400" cy="457200"/>
           </a:xfrm>
           <a:prstGeom prst="rect">
             <a:avLst/>
@@ -3140,16 +3138,15 @@
           <a:noFill/>
         </p:spPr>
         <p:txBody>
-          <a:bodyPr wrap="square" anchor="t">
+          <a:bodyPr wrap="square">
             <a:spAutoFit/>
           </a:bodyPr>
           <a:lstStyle/>
           <a:p>
-            <a:pPr algn="l"/>
-            <a:r>
-              <a:rPr sz="1500" b="1">
+            <a:r>
+              <a:rPr sz="2200" b="1">
                 <a:solidFill>
-                  <a:srgbClr val="E7C14B"/>
+                  <a:srgbClr val="F2B133"/>
                 </a:solidFill>
                 <a:latin typeface="Segoe UI"/>
               </a:rPr>
@@ -3166,8 +3163,8 @@
         </p:nvSpPr>
         <p:spPr>
           <a:xfrm>
-            <a:off x="548640" y="4389120"/>
-            <a:ext cx="9692640" cy="1371600"/>
+            <a:off x="548640" y="3200400"/>
+            <a:ext cx="10058400" cy="914400"/>
           </a:xfrm>
           <a:prstGeom prst="rect">
             <a:avLst/>
@@ -3175,14 +3172,13 @@
           <a:noFill/>
         </p:spPr>
         <p:txBody>
-          <a:bodyPr wrap="square" anchor="t">
+          <a:bodyPr wrap="square">
             <a:spAutoFit/>
           </a:bodyPr>
           <a:lstStyle/>
           <a:p>
-            <a:pPr algn="l"/>
-            <a:r>
-              <a:rPr sz="3200" b="1">
+            <a:r>
+              <a:rPr sz="4100" b="1">
                 <a:solidFill>
                   <a:srgbClr val="FFFFFF"/>
                 </a:solidFill>
@@ -3201,8 +3197,8 @@
         </p:nvSpPr>
         <p:spPr>
           <a:xfrm>
-            <a:off x="566928" y="5623560"/>
-            <a:ext cx="9692640" cy="457200"/>
+            <a:off x="566928" y="4224528"/>
+            <a:ext cx="10058400" cy="457200"/>
           </a:xfrm>
           <a:prstGeom prst="rect">
             <a:avLst/>
@@ -3210,16 +3206,15 @@
           <a:noFill/>
         </p:spPr>
         <p:txBody>
-          <a:bodyPr wrap="square" anchor="t">
+          <a:bodyPr wrap="square">
             <a:spAutoFit/>
           </a:bodyPr>
           <a:lstStyle/>
           <a:p>
-            <a:pPr algn="l"/>
-            <a:r>
-              <a:rPr sz="1550" b="0">
+            <a:r>
+              <a:rPr sz="1800" b="0">
                 <a:solidFill>
-                  <a:srgbClr val="DDE9F0"/>
+                  <a:srgbClr val="CFE6F2"/>
                 </a:solidFill>
                 <a:latin typeface="Segoe UI"/>
               </a:rPr>
@@ -3236,8 +3231,8 @@
         </p:nvSpPr>
         <p:spPr>
           <a:xfrm>
-            <a:off x="566928" y="6108192"/>
-            <a:ext cx="9692640" cy="365760"/>
+            <a:off x="566928" y="4800600"/>
+            <a:ext cx="10058400" cy="365760"/>
           </a:xfrm>
           <a:prstGeom prst="rect">
             <a:avLst/>
@@ -3245,20 +3240,19 @@
           <a:noFill/>
         </p:spPr>
         <p:txBody>
-          <a:bodyPr wrap="square" anchor="t">
+          <a:bodyPr wrap="square">
             <a:spAutoFit/>
           </a:bodyPr>
           <a:lstStyle/>
           <a:p>
-            <a:pPr algn="l"/>
-            <a:r>
-              <a:rPr sz="1350" b="1">
+            <a:r>
+              <a:rPr sz="1400" b="1">
                 <a:solidFill>
                   <a:srgbClr val="FFFFFF"/>
                 </a:solidFill>
                 <a:latin typeface="Segoe UI"/>
               </a:rPr>
-              <a:t>Docentes: Damian Giacone, Ariel Giamportone</a:t>
+              <a:t>Docentes: Damián Giacone · Ariel Giamportone</a:t>
             </a:r>
           </a:p>
         </p:txBody>
@@ -3271,8 +3265,8 @@
         </p:nvSpPr>
         <p:spPr>
           <a:xfrm>
-            <a:off x="566928" y="6455664"/>
-            <a:ext cx="10789920" cy="320040"/>
+            <a:off x="566928" y="5138928"/>
+            <a:ext cx="10058400" cy="365760"/>
           </a:xfrm>
           <a:prstGeom prst="rect">
             <a:avLst/>
@@ -3280,20 +3274,19 @@
           <a:noFill/>
         </p:spPr>
         <p:txBody>
-          <a:bodyPr wrap="square" anchor="t">
+          <a:bodyPr wrap="square">
             <a:spAutoFit/>
           </a:bodyPr>
           <a:lstStyle/>
           <a:p>
-            <a:pPr algn="l"/>
-            <a:r>
-              <a:rPr sz="1000" b="0">
+            <a:r>
+              <a:rPr sz="1150" b="0">
                 <a:solidFill>
-                  <a:srgbClr val="DDE9F0"/>
+                  <a:srgbClr val="AFCEDE"/>
                 </a:solidFill>
                 <a:latin typeface="Segoe UI"/>
               </a:rPr>
-              <a:t>Inteligencia Artificial Aplicada a la Producción Pesquera  |  UTN FRCh  |  2026</a:t>
+              <a:t>Inteligencia Artificial Aplicada a la Producción Pesquera  |  UTN FRCh  |  PesquerosEnIA  |  2026</a:t>
             </a:r>
           </a:p>
         </p:txBody>
@@ -3318,7 +3311,7 @@
       <p:grpSpPr/>
       <p:pic>
         <p:nvPicPr>
-          <p:cNvPr id="2" name="Picture 1" descr="c6_3.png"/>
+          <p:cNvPr id="2" name="Picture 1" descr="img_cierre.png"/>
           <p:cNvPicPr>
             <a:picLocks noChangeAspect="1"/>
           </p:cNvPicPr>
@@ -3333,91 +3326,7 @@
         <p:spPr>
           <a:xfrm>
             <a:off x="0" y="0"/>
-            <a:ext cx="12191695" cy="6858000"/>
-          </a:xfrm>
-          <a:prstGeom prst="rect">
-            <a:avLst/>
-          </a:prstGeom>
-        </p:spPr>
-      </p:pic>
-    </p:spTree>
-  </p:cSld>
-  <p:clrMapOvr>
-    <a:masterClrMapping/>
-  </p:clrMapOvr>
-</p:sld>
-</file>
-
-<file path=ppt/slides/slide11.xml><?xml version="1.0" encoding="utf-8"?>
-<p:sld xmlns:a="http://schemas.openxmlformats.org/drawingml/2006/main" xmlns:p="http://schemas.openxmlformats.org/presentationml/2006/main" xmlns:r="http://schemas.openxmlformats.org/officeDocument/2006/relationships">
-  <p:cSld>
-    <p:spTree>
-      <p:nvGrpSpPr>
-        <p:cNvPr id="1" name=""/>
-        <p:cNvGrpSpPr/>
-        <p:nvPr/>
-      </p:nvGrpSpPr>
-      <p:grpSpPr/>
-      <p:pic>
-        <p:nvPicPr>
-          <p:cNvPr id="2" name="Picture 1" descr="c6_d1.png"/>
-          <p:cNvPicPr>
-            <a:picLocks noChangeAspect="1"/>
-          </p:cNvPicPr>
-          <p:nvPr/>
-        </p:nvPicPr>
-        <p:blipFill>
-          <a:blip r:embed="rId2"/>
-          <a:stretch>
-            <a:fillRect/>
-          </a:stretch>
-        </p:blipFill>
-        <p:spPr>
-          <a:xfrm>
-            <a:off x="0" y="0"/>
-            <a:ext cx="12191695" cy="6858000"/>
-          </a:xfrm>
-          <a:prstGeom prst="rect">
-            <a:avLst/>
-          </a:prstGeom>
-        </p:spPr>
-      </p:pic>
-    </p:spTree>
-  </p:cSld>
-  <p:clrMapOvr>
-    <a:masterClrMapping/>
-  </p:clrMapOvr>
-</p:sld>
-</file>
-
-<file path=ppt/slides/slide12.xml><?xml version="1.0" encoding="utf-8"?>
-<p:sld xmlns:a="http://schemas.openxmlformats.org/drawingml/2006/main" xmlns:p="http://schemas.openxmlformats.org/presentationml/2006/main" xmlns:r="http://schemas.openxmlformats.org/officeDocument/2006/relationships">
-  <p:cSld>
-    <p:spTree>
-      <p:nvGrpSpPr>
-        <p:cNvPr id="1" name=""/>
-        <p:cNvGrpSpPr/>
-        <p:nvPr/>
-      </p:nvGrpSpPr>
-      <p:grpSpPr/>
-      <p:pic>
-        <p:nvPicPr>
-          <p:cNvPr id="2" name="Picture 1" descr="c6_d2.png"/>
-          <p:cNvPicPr>
-            <a:picLocks noChangeAspect="1"/>
-          </p:cNvPicPr>
-          <p:nvPr/>
-        </p:nvPicPr>
-        <p:blipFill>
-          <a:blip r:embed="rId2"/>
-          <a:stretch>
-            <a:fillRect/>
-          </a:stretch>
-        </p:blipFill>
-        <p:spPr>
-          <a:xfrm>
-            <a:off x="0" y="0"/>
-            <a:ext cx="12191695" cy="6858000"/>
+            <a:ext cx="12192000" cy="6858000"/>
           </a:xfrm>
           <a:prstGeom prst="rect">
             <a:avLst/>
@@ -3442,377 +3351,9 @@
         <p:nvPr/>
       </p:nvGrpSpPr>
       <p:grpSpPr/>
-      <p:sp>
-        <p:nvSpPr>
-          <p:cNvPr id="2" name="Rectangle 1"/>
-          <p:cNvSpPr/>
-          <p:nvPr/>
-        </p:nvSpPr>
-        <p:spPr>
-          <a:xfrm>
-            <a:off x="0" y="0"/>
-            <a:ext cx="12191695" cy="6858000"/>
-          </a:xfrm>
-          <a:prstGeom prst="rect">
-            <a:avLst/>
-          </a:prstGeom>
-          <a:solidFill>
-            <a:srgbClr val="F5F7FA"/>
-          </a:solidFill>
-          <a:ln>
-            <a:noFill/>
-          </a:ln>
-          <a:effectLst/>
-        </p:spPr>
-        <p:style>
-          <a:lnRef idx="1">
-            <a:schemeClr val="accent1"/>
-          </a:lnRef>
-          <a:fillRef idx="3">
-            <a:schemeClr val="accent1"/>
-          </a:fillRef>
-          <a:effectRef idx="2">
-            <a:schemeClr val="accent1"/>
-          </a:effectRef>
-          <a:fontRef idx="minor">
-            <a:schemeClr val="lt1"/>
-          </a:fontRef>
-        </p:style>
-        <p:txBody>
-          <a:bodyPr rtlCol="0" anchor="ctr"/>
-          <a:lstStyle/>
-          <a:p>
-            <a:pPr algn="ctr"/>
-          </a:p>
-        </p:txBody>
-      </p:sp>
-      <p:sp>
-        <p:nvSpPr>
-          <p:cNvPr id="3" name="Rectangle 2"/>
-          <p:cNvSpPr/>
-          <p:nvPr/>
-        </p:nvSpPr>
-        <p:spPr>
-          <a:xfrm>
-            <a:off x="0" y="0"/>
-            <a:ext cx="201168" cy="6858000"/>
-          </a:xfrm>
-          <a:prstGeom prst="rect">
-            <a:avLst/>
-          </a:prstGeom>
-          <a:solidFill>
-            <a:srgbClr val="962D37"/>
-          </a:solidFill>
-          <a:ln>
-            <a:noFill/>
-          </a:ln>
-          <a:effectLst/>
-        </p:spPr>
-        <p:style>
-          <a:lnRef idx="1">
-            <a:schemeClr val="accent1"/>
-          </a:lnRef>
-          <a:fillRef idx="3">
-            <a:schemeClr val="accent1"/>
-          </a:fillRef>
-          <a:effectRef idx="2">
-            <a:schemeClr val="accent1"/>
-          </a:effectRef>
-          <a:fontRef idx="minor">
-            <a:schemeClr val="lt1"/>
-          </a:fontRef>
-        </p:style>
-        <p:txBody>
-          <a:bodyPr rtlCol="0" anchor="ctr"/>
-          <a:lstStyle/>
-          <a:p>
-            <a:pPr algn="ctr"/>
-          </a:p>
-        </p:txBody>
-      </p:sp>
-      <p:sp>
-        <p:nvSpPr>
-          <p:cNvPr id="4" name="Rectangle 3"/>
-          <p:cNvSpPr/>
-          <p:nvPr/>
-        </p:nvSpPr>
-        <p:spPr>
-          <a:xfrm>
-            <a:off x="0" y="0"/>
-            <a:ext cx="12191695" cy="1371600"/>
-          </a:xfrm>
-          <a:prstGeom prst="rect">
-            <a:avLst/>
-          </a:prstGeom>
-          <a:solidFill>
-            <a:srgbClr val="962D37"/>
-          </a:solidFill>
-          <a:ln>
-            <a:noFill/>
-          </a:ln>
-          <a:effectLst/>
-        </p:spPr>
-        <p:style>
-          <a:lnRef idx="1">
-            <a:schemeClr val="accent1"/>
-          </a:lnRef>
-          <a:fillRef idx="3">
-            <a:schemeClr val="accent1"/>
-          </a:fillRef>
-          <a:effectRef idx="2">
-            <a:schemeClr val="accent1"/>
-          </a:effectRef>
-          <a:fontRef idx="minor">
-            <a:schemeClr val="lt1"/>
-          </a:fontRef>
-        </p:style>
-        <p:txBody>
-          <a:bodyPr rtlCol="0" anchor="ctr"/>
-          <a:lstStyle/>
-          <a:p>
-            <a:pPr algn="ctr"/>
-          </a:p>
-        </p:txBody>
-      </p:sp>
-      <p:sp>
-        <p:nvSpPr>
-          <p:cNvPr id="5" name="TextBox 4"/>
-          <p:cNvSpPr txBox="1"/>
-          <p:nvPr/>
-        </p:nvSpPr>
-        <p:spPr>
-          <a:xfrm>
-            <a:off x="365760" y="73152"/>
-            <a:ext cx="11247120" cy="411480"/>
-          </a:xfrm>
-          <a:prstGeom prst="rect">
-            <a:avLst/>
-          </a:prstGeom>
-          <a:noFill/>
-        </p:spPr>
-        <p:txBody>
-          <a:bodyPr wrap="square" anchor="t">
-            <a:spAutoFit/>
-          </a:bodyPr>
-          <a:lstStyle/>
-          <a:p>
-            <a:pPr algn="l"/>
-            <a:r>
-              <a:rPr sz="1300" b="1">
-                <a:solidFill>
-                  <a:srgbClr val="E7C14B"/>
-                </a:solidFill>
-                <a:latin typeface="Segoe UI"/>
-              </a:rPr>
-              <a:t>AGENDA DE LA CLASE</a:t>
-            </a:r>
-          </a:p>
-        </p:txBody>
-      </p:sp>
-      <p:sp>
-        <p:nvSpPr>
-          <p:cNvPr id="6" name="TextBox 5"/>
-          <p:cNvSpPr txBox="1"/>
-          <p:nvPr/>
-        </p:nvSpPr>
-        <p:spPr>
-          <a:xfrm>
-            <a:off x="365760" y="384048"/>
-            <a:ext cx="11064240" cy="914400"/>
-          </a:xfrm>
-          <a:prstGeom prst="rect">
-            <a:avLst/>
-          </a:prstGeom>
-          <a:noFill/>
-        </p:spPr>
-        <p:txBody>
-          <a:bodyPr wrap="square" anchor="t">
-            <a:spAutoFit/>
-          </a:bodyPr>
-          <a:lstStyle/>
-          <a:p>
-            <a:pPr algn="l"/>
-            <a:r>
-              <a:rPr sz="2600" b="1">
-                <a:solidFill>
-                  <a:srgbClr val="FFFFFF"/>
-                </a:solidFill>
-                <a:latin typeface="Segoe UI"/>
-              </a:rPr>
-              <a:t>Lo que vamos a ver hoy</a:t>
-            </a:r>
-          </a:p>
-        </p:txBody>
-      </p:sp>
-      <p:sp>
-        <p:nvSpPr>
-          <p:cNvPr id="7" name="TextBox 6"/>
-          <p:cNvSpPr txBox="1"/>
-          <p:nvPr/>
-        </p:nvSpPr>
-        <p:spPr>
-          <a:xfrm>
-            <a:off x="502920" y="1691640"/>
-            <a:ext cx="11155680" cy="4572000"/>
-          </a:xfrm>
-          <a:prstGeom prst="rect">
-            <a:avLst/>
-          </a:prstGeom>
-          <a:noFill/>
-        </p:spPr>
-        <p:txBody>
-          <a:bodyPr wrap="square">
-            <a:spAutoFit/>
-          </a:bodyPr>
-          <a:lstStyle/>
-          <a:p>
-            <a:pPr>
-              <a:spcAft>
-                <a:spcPts val="1400"/>
-              </a:spcAft>
-            </a:pPr>
-            <a:r>
-              <a:rPr sz="1900">
-                <a:solidFill>
-                  <a:srgbClr val="1E1E32"/>
-                </a:solidFill>
-                <a:latin typeface="Segoe UI"/>
-              </a:rPr>
-              <a:t>•  Qué es el Machine Learning y cómo "aprende"</a:t>
-            </a:r>
-          </a:p>
-          <a:p>
-            <a:pPr>
-              <a:spcAft>
-                <a:spcPts val="1400"/>
-              </a:spcAft>
-            </a:pPr>
-            <a:r>
-              <a:rPr sz="1900">
-                <a:solidFill>
-                  <a:srgbClr val="1E1E32"/>
-                </a:solidFill>
-                <a:latin typeface="Segoe UI"/>
-              </a:rPr>
-              <a:t>•  Entrenar y evaluar: por qué importa</a:t>
-            </a:r>
-          </a:p>
-          <a:p>
-            <a:pPr>
-              <a:spcAft>
-                <a:spcPts val="1400"/>
-              </a:spcAft>
-            </a:pPr>
-            <a:r>
-              <a:rPr sz="1900">
-                <a:solidFill>
-                  <a:srgbClr val="1E1E32"/>
-                </a:solidFill>
-                <a:latin typeface="Segoe UI"/>
-              </a:rPr>
-              <a:t>•  Evaluación honesta: ROC y los dos errores</a:t>
-            </a:r>
-          </a:p>
-          <a:p>
-            <a:pPr>
-              <a:spcAft>
-                <a:spcPts val="1400"/>
-              </a:spcAft>
-            </a:pPr>
-            <a:r>
-              <a:rPr sz="1900">
-                <a:solidFill>
-                  <a:srgbClr val="1E1E32"/>
-                </a:solidFill>
-                <a:latin typeface="Segoe UI"/>
-              </a:rPr>
-              <a:t>•  De "¿voy?" a "¿cuántos kg?" + ética</a:t>
-            </a:r>
-          </a:p>
-        </p:txBody>
-      </p:sp>
-      <p:sp>
-        <p:nvSpPr>
-          <p:cNvPr id="8" name="Rectangle 7"/>
-          <p:cNvSpPr/>
-          <p:nvPr/>
-        </p:nvSpPr>
-        <p:spPr>
-          <a:xfrm>
-            <a:off x="0" y="6419088"/>
-            <a:ext cx="12191695" cy="438912"/>
-          </a:xfrm>
-          <a:prstGeom prst="rect">
-            <a:avLst/>
-          </a:prstGeom>
-          <a:solidFill>
-            <a:srgbClr val="962D37"/>
-          </a:solidFill>
-          <a:ln>
-            <a:noFill/>
-          </a:ln>
-          <a:effectLst/>
-        </p:spPr>
-        <p:style>
-          <a:lnRef idx="1">
-            <a:schemeClr val="accent1"/>
-          </a:lnRef>
-          <a:fillRef idx="3">
-            <a:schemeClr val="accent1"/>
-          </a:fillRef>
-          <a:effectRef idx="2">
-            <a:schemeClr val="accent1"/>
-          </a:effectRef>
-          <a:fontRef idx="minor">
-            <a:schemeClr val="lt1"/>
-          </a:fontRef>
-        </p:style>
-        <p:txBody>
-          <a:bodyPr rtlCol="0" anchor="ctr"/>
-          <a:lstStyle/>
-          <a:p>
-            <a:pPr algn="ctr"/>
-          </a:p>
-        </p:txBody>
-      </p:sp>
-      <p:sp>
-        <p:nvSpPr>
-          <p:cNvPr id="9" name="TextBox 8"/>
-          <p:cNvSpPr txBox="1"/>
-          <p:nvPr/>
-        </p:nvSpPr>
-        <p:spPr>
-          <a:xfrm>
-            <a:off x="566928" y="6473952"/>
-            <a:ext cx="11430000" cy="329184"/>
-          </a:xfrm>
-          <a:prstGeom prst="rect">
-            <a:avLst/>
-          </a:prstGeom>
-          <a:noFill/>
-        </p:spPr>
-        <p:txBody>
-          <a:bodyPr wrap="square" anchor="t">
-            <a:spAutoFit/>
-          </a:bodyPr>
-          <a:lstStyle/>
-          <a:p>
-            <a:pPr algn="l"/>
-            <a:r>
-              <a:rPr sz="1000" b="0">
-                <a:solidFill>
-                  <a:srgbClr val="FFFFFF"/>
-                </a:solidFill>
-                <a:latin typeface="Segoe UI"/>
-              </a:rPr>
-              <a:t>IA Aplicada a la Producción Pesquera   |   UTN FRCh   |   PesquerosEnIA   |   2026</a:t>
-            </a:r>
-          </a:p>
-        </p:txBody>
-      </p:sp>
       <p:pic>
         <p:nvPicPr>
-          <p:cNvPr id="10" name="Picture 9" descr="fishlogo.png"/>
+          <p:cNvPr id="2" name="Picture 1" descr="img_agenda.png"/>
           <p:cNvPicPr>
             <a:picLocks noChangeAspect="1"/>
           </p:cNvPicPr>
@@ -3826,8 +3367,8 @@
         </p:blipFill>
         <p:spPr>
           <a:xfrm>
-            <a:off x="137160" y="6455664"/>
-            <a:ext cx="347472" cy="347472"/>
+            <a:off x="0" y="0"/>
+            <a:ext cx="12192000" cy="6858000"/>
           </a:xfrm>
           <a:prstGeom prst="rect">
             <a:avLst/>
@@ -3852,377 +3393,9 @@
         <p:nvPr/>
       </p:nvGrpSpPr>
       <p:grpSpPr/>
-      <p:sp>
-        <p:nvSpPr>
-          <p:cNvPr id="2" name="Rectangle 1"/>
-          <p:cNvSpPr/>
-          <p:nvPr/>
-        </p:nvSpPr>
-        <p:spPr>
-          <a:xfrm>
-            <a:off x="0" y="0"/>
-            <a:ext cx="12191695" cy="6858000"/>
-          </a:xfrm>
-          <a:prstGeom prst="rect">
-            <a:avLst/>
-          </a:prstGeom>
-          <a:solidFill>
-            <a:srgbClr val="F5F7FA"/>
-          </a:solidFill>
-          <a:ln>
-            <a:noFill/>
-          </a:ln>
-          <a:effectLst/>
-        </p:spPr>
-        <p:style>
-          <a:lnRef idx="1">
-            <a:schemeClr val="accent1"/>
-          </a:lnRef>
-          <a:fillRef idx="3">
-            <a:schemeClr val="accent1"/>
-          </a:fillRef>
-          <a:effectRef idx="2">
-            <a:schemeClr val="accent1"/>
-          </a:effectRef>
-          <a:fontRef idx="minor">
-            <a:schemeClr val="lt1"/>
-          </a:fontRef>
-        </p:style>
-        <p:txBody>
-          <a:bodyPr rtlCol="0" anchor="ctr"/>
-          <a:lstStyle/>
-          <a:p>
-            <a:pPr algn="ctr"/>
-          </a:p>
-        </p:txBody>
-      </p:sp>
-      <p:sp>
-        <p:nvSpPr>
-          <p:cNvPr id="3" name="Rectangle 2"/>
-          <p:cNvSpPr/>
-          <p:nvPr/>
-        </p:nvSpPr>
-        <p:spPr>
-          <a:xfrm>
-            <a:off x="0" y="0"/>
-            <a:ext cx="201168" cy="6858000"/>
-          </a:xfrm>
-          <a:prstGeom prst="rect">
-            <a:avLst/>
-          </a:prstGeom>
-          <a:solidFill>
-            <a:srgbClr val="962D37"/>
-          </a:solidFill>
-          <a:ln>
-            <a:noFill/>
-          </a:ln>
-          <a:effectLst/>
-        </p:spPr>
-        <p:style>
-          <a:lnRef idx="1">
-            <a:schemeClr val="accent1"/>
-          </a:lnRef>
-          <a:fillRef idx="3">
-            <a:schemeClr val="accent1"/>
-          </a:fillRef>
-          <a:effectRef idx="2">
-            <a:schemeClr val="accent1"/>
-          </a:effectRef>
-          <a:fontRef idx="minor">
-            <a:schemeClr val="lt1"/>
-          </a:fontRef>
-        </p:style>
-        <p:txBody>
-          <a:bodyPr rtlCol="0" anchor="ctr"/>
-          <a:lstStyle/>
-          <a:p>
-            <a:pPr algn="ctr"/>
-          </a:p>
-        </p:txBody>
-      </p:sp>
-      <p:sp>
-        <p:nvSpPr>
-          <p:cNvPr id="4" name="Rectangle 3"/>
-          <p:cNvSpPr/>
-          <p:nvPr/>
-        </p:nvSpPr>
-        <p:spPr>
-          <a:xfrm>
-            <a:off x="0" y="0"/>
-            <a:ext cx="12191695" cy="1371600"/>
-          </a:xfrm>
-          <a:prstGeom prst="rect">
-            <a:avLst/>
-          </a:prstGeom>
-          <a:solidFill>
-            <a:srgbClr val="962D37"/>
-          </a:solidFill>
-          <a:ln>
-            <a:noFill/>
-          </a:ln>
-          <a:effectLst/>
-        </p:spPr>
-        <p:style>
-          <a:lnRef idx="1">
-            <a:schemeClr val="accent1"/>
-          </a:lnRef>
-          <a:fillRef idx="3">
-            <a:schemeClr val="accent1"/>
-          </a:fillRef>
-          <a:effectRef idx="2">
-            <a:schemeClr val="accent1"/>
-          </a:effectRef>
-          <a:fontRef idx="minor">
-            <a:schemeClr val="lt1"/>
-          </a:fontRef>
-        </p:style>
-        <p:txBody>
-          <a:bodyPr rtlCol="0" anchor="ctr"/>
-          <a:lstStyle/>
-          <a:p>
-            <a:pPr algn="ctr"/>
-          </a:p>
-        </p:txBody>
-      </p:sp>
-      <p:sp>
-        <p:nvSpPr>
-          <p:cNvPr id="5" name="TextBox 4"/>
-          <p:cNvSpPr txBox="1"/>
-          <p:nvPr/>
-        </p:nvSpPr>
-        <p:spPr>
-          <a:xfrm>
-            <a:off x="365760" y="73152"/>
-            <a:ext cx="11247120" cy="411480"/>
-          </a:xfrm>
-          <a:prstGeom prst="rect">
-            <a:avLst/>
-          </a:prstGeom>
-          <a:noFill/>
-        </p:spPr>
-        <p:txBody>
-          <a:bodyPr wrap="square" anchor="t">
-            <a:spAutoFit/>
-          </a:bodyPr>
-          <a:lstStyle/>
-          <a:p>
-            <a:pPr algn="l"/>
-            <a:r>
-              <a:rPr sz="1300" b="1">
-                <a:solidFill>
-                  <a:srgbClr val="E7C14B"/>
-                </a:solidFill>
-                <a:latin typeface="Segoe UI"/>
-              </a:rPr>
-              <a:t>APRENDER DE DATOS</a:t>
-            </a:r>
-          </a:p>
-        </p:txBody>
-      </p:sp>
-      <p:sp>
-        <p:nvSpPr>
-          <p:cNvPr id="6" name="TextBox 5"/>
-          <p:cNvSpPr txBox="1"/>
-          <p:nvPr/>
-        </p:nvSpPr>
-        <p:spPr>
-          <a:xfrm>
-            <a:off x="365760" y="384048"/>
-            <a:ext cx="11064240" cy="914400"/>
-          </a:xfrm>
-          <a:prstGeom prst="rect">
-            <a:avLst/>
-          </a:prstGeom>
-          <a:noFill/>
-        </p:spPr>
-        <p:txBody>
-          <a:bodyPr wrap="square" anchor="t">
-            <a:spAutoFit/>
-          </a:bodyPr>
-          <a:lstStyle/>
-          <a:p>
-            <a:pPr algn="l"/>
-            <a:r>
-              <a:rPr sz="2600" b="1">
-                <a:solidFill>
-                  <a:srgbClr val="FFFFFF"/>
-                </a:solidFill>
-                <a:latin typeface="Segoe UI"/>
-              </a:rPr>
-              <a:t>¿Qué es el Machine Learning?</a:t>
-            </a:r>
-          </a:p>
-        </p:txBody>
-      </p:sp>
-      <p:sp>
-        <p:nvSpPr>
-          <p:cNvPr id="7" name="TextBox 6"/>
-          <p:cNvSpPr txBox="1"/>
-          <p:nvPr/>
-        </p:nvSpPr>
-        <p:spPr>
-          <a:xfrm>
-            <a:off x="502920" y="1691640"/>
-            <a:ext cx="11155680" cy="4572000"/>
-          </a:xfrm>
-          <a:prstGeom prst="rect">
-            <a:avLst/>
-          </a:prstGeom>
-          <a:noFill/>
-        </p:spPr>
-        <p:txBody>
-          <a:bodyPr wrap="square">
-            <a:spAutoFit/>
-          </a:bodyPr>
-          <a:lstStyle/>
-          <a:p>
-            <a:pPr>
-              <a:spcAft>
-                <a:spcPts val="1400"/>
-              </a:spcAft>
-            </a:pPr>
-            <a:r>
-              <a:rPr sz="1900">
-                <a:solidFill>
-                  <a:srgbClr val="1E1E32"/>
-                </a:solidFill>
-                <a:latin typeface="Segoe UI"/>
-              </a:rPr>
-              <a:t>•  Aprende de ejemplos, no de reglas fijas</a:t>
-            </a:r>
-          </a:p>
-          <a:p>
-            <a:pPr>
-              <a:spcAft>
-                <a:spcPts val="1400"/>
-              </a:spcAft>
-            </a:pPr>
-            <a:r>
-              <a:rPr sz="1900">
-                <a:solidFill>
-                  <a:srgbClr val="1E1E32"/>
-                </a:solidFill>
-                <a:latin typeface="Segoe UI"/>
-              </a:rPr>
-              <a:t>•  Le mostramos mil mareas pasadas y encuentra el patrón</a:t>
-            </a:r>
-          </a:p>
-          <a:p>
-            <a:pPr>
-              <a:spcAft>
-                <a:spcPts val="1400"/>
-              </a:spcAft>
-            </a:pPr>
-            <a:r>
-              <a:rPr sz="1900">
-                <a:solidFill>
-                  <a:srgbClr val="1E1E32"/>
-                </a:solidFill>
-                <a:latin typeface="Segoe UI"/>
-              </a:rPr>
-              <a:t>•  Como un capitán experimentado, mirando cientos de variables a la vez</a:t>
-            </a:r>
-          </a:p>
-          <a:p>
-            <a:pPr>
-              <a:spcAft>
-                <a:spcPts val="1400"/>
-              </a:spcAft>
-            </a:pPr>
-            <a:r>
-              <a:rPr sz="1900">
-                <a:solidFill>
-                  <a:srgbClr val="1E1E32"/>
-                </a:solidFill>
-                <a:latin typeface="Segoe UI"/>
-              </a:rPr>
-              <a:t>•  Generaliza; no memoriza</a:t>
-            </a:r>
-          </a:p>
-        </p:txBody>
-      </p:sp>
-      <p:sp>
-        <p:nvSpPr>
-          <p:cNvPr id="8" name="Rectangle 7"/>
-          <p:cNvSpPr/>
-          <p:nvPr/>
-        </p:nvSpPr>
-        <p:spPr>
-          <a:xfrm>
-            <a:off x="0" y="6419088"/>
-            <a:ext cx="12191695" cy="438912"/>
-          </a:xfrm>
-          <a:prstGeom prst="rect">
-            <a:avLst/>
-          </a:prstGeom>
-          <a:solidFill>
-            <a:srgbClr val="962D37"/>
-          </a:solidFill>
-          <a:ln>
-            <a:noFill/>
-          </a:ln>
-          <a:effectLst/>
-        </p:spPr>
-        <p:style>
-          <a:lnRef idx="1">
-            <a:schemeClr val="accent1"/>
-          </a:lnRef>
-          <a:fillRef idx="3">
-            <a:schemeClr val="accent1"/>
-          </a:fillRef>
-          <a:effectRef idx="2">
-            <a:schemeClr val="accent1"/>
-          </a:effectRef>
-          <a:fontRef idx="minor">
-            <a:schemeClr val="lt1"/>
-          </a:fontRef>
-        </p:style>
-        <p:txBody>
-          <a:bodyPr rtlCol="0" anchor="ctr"/>
-          <a:lstStyle/>
-          <a:p>
-            <a:pPr algn="ctr"/>
-          </a:p>
-        </p:txBody>
-      </p:sp>
-      <p:sp>
-        <p:nvSpPr>
-          <p:cNvPr id="9" name="TextBox 8"/>
-          <p:cNvSpPr txBox="1"/>
-          <p:nvPr/>
-        </p:nvSpPr>
-        <p:spPr>
-          <a:xfrm>
-            <a:off x="566928" y="6473952"/>
-            <a:ext cx="11430000" cy="329184"/>
-          </a:xfrm>
-          <a:prstGeom prst="rect">
-            <a:avLst/>
-          </a:prstGeom>
-          <a:noFill/>
-        </p:spPr>
-        <p:txBody>
-          <a:bodyPr wrap="square" anchor="t">
-            <a:spAutoFit/>
-          </a:bodyPr>
-          <a:lstStyle/>
-          <a:p>
-            <a:pPr algn="l"/>
-            <a:r>
-              <a:rPr sz="1000" b="0">
-                <a:solidFill>
-                  <a:srgbClr val="FFFFFF"/>
-                </a:solidFill>
-                <a:latin typeface="Segoe UI"/>
-              </a:rPr>
-              <a:t>IA Aplicada a la Producción Pesquera   |   UTN FRCh   |   PesquerosEnIA   |   2026</a:t>
-            </a:r>
-          </a:p>
-        </p:txBody>
-      </p:sp>
       <p:pic>
         <p:nvPicPr>
-          <p:cNvPr id="10" name="Picture 9" descr="fishlogo.png"/>
+          <p:cNvPr id="2" name="Picture 1" descr="reuse_aprender.png"/>
           <p:cNvPicPr>
             <a:picLocks noChangeAspect="1"/>
           </p:cNvPicPr>
@@ -4236,8 +3409,8 @@
         </p:blipFill>
         <p:spPr>
           <a:xfrm>
-            <a:off x="137160" y="6455664"/>
-            <a:ext cx="347472" cy="347472"/>
+            <a:off x="0" y="0"/>
+            <a:ext cx="12192000" cy="6858000"/>
           </a:xfrm>
           <a:prstGeom prst="rect">
             <a:avLst/>
@@ -4262,361 +3435,9 @@
         <p:nvPr/>
       </p:nvGrpSpPr>
       <p:grpSpPr/>
-      <p:sp>
-        <p:nvSpPr>
-          <p:cNvPr id="2" name="Rectangle 1"/>
-          <p:cNvSpPr/>
-          <p:nvPr/>
-        </p:nvSpPr>
-        <p:spPr>
-          <a:xfrm>
-            <a:off x="0" y="0"/>
-            <a:ext cx="12191695" cy="6858000"/>
-          </a:xfrm>
-          <a:prstGeom prst="rect">
-            <a:avLst/>
-          </a:prstGeom>
-          <a:solidFill>
-            <a:srgbClr val="F5F7FA"/>
-          </a:solidFill>
-          <a:ln>
-            <a:noFill/>
-          </a:ln>
-          <a:effectLst/>
-        </p:spPr>
-        <p:style>
-          <a:lnRef idx="1">
-            <a:schemeClr val="accent1"/>
-          </a:lnRef>
-          <a:fillRef idx="3">
-            <a:schemeClr val="accent1"/>
-          </a:fillRef>
-          <a:effectRef idx="2">
-            <a:schemeClr val="accent1"/>
-          </a:effectRef>
-          <a:fontRef idx="minor">
-            <a:schemeClr val="lt1"/>
-          </a:fontRef>
-        </p:style>
-        <p:txBody>
-          <a:bodyPr rtlCol="0" anchor="ctr"/>
-          <a:lstStyle/>
-          <a:p>
-            <a:pPr algn="ctr"/>
-          </a:p>
-        </p:txBody>
-      </p:sp>
-      <p:sp>
-        <p:nvSpPr>
-          <p:cNvPr id="3" name="Rectangle 2"/>
-          <p:cNvSpPr/>
-          <p:nvPr/>
-        </p:nvSpPr>
-        <p:spPr>
-          <a:xfrm>
-            <a:off x="0" y="0"/>
-            <a:ext cx="201168" cy="6858000"/>
-          </a:xfrm>
-          <a:prstGeom prst="rect">
-            <a:avLst/>
-          </a:prstGeom>
-          <a:solidFill>
-            <a:srgbClr val="962D37"/>
-          </a:solidFill>
-          <a:ln>
-            <a:noFill/>
-          </a:ln>
-          <a:effectLst/>
-        </p:spPr>
-        <p:style>
-          <a:lnRef idx="1">
-            <a:schemeClr val="accent1"/>
-          </a:lnRef>
-          <a:fillRef idx="3">
-            <a:schemeClr val="accent1"/>
-          </a:fillRef>
-          <a:effectRef idx="2">
-            <a:schemeClr val="accent1"/>
-          </a:effectRef>
-          <a:fontRef idx="minor">
-            <a:schemeClr val="lt1"/>
-          </a:fontRef>
-        </p:style>
-        <p:txBody>
-          <a:bodyPr rtlCol="0" anchor="ctr"/>
-          <a:lstStyle/>
-          <a:p>
-            <a:pPr algn="ctr"/>
-          </a:p>
-        </p:txBody>
-      </p:sp>
-      <p:sp>
-        <p:nvSpPr>
-          <p:cNvPr id="4" name="Rectangle 3"/>
-          <p:cNvSpPr/>
-          <p:nvPr/>
-        </p:nvSpPr>
-        <p:spPr>
-          <a:xfrm>
-            <a:off x="0" y="0"/>
-            <a:ext cx="12191695" cy="1371600"/>
-          </a:xfrm>
-          <a:prstGeom prst="rect">
-            <a:avLst/>
-          </a:prstGeom>
-          <a:solidFill>
-            <a:srgbClr val="962D37"/>
-          </a:solidFill>
-          <a:ln>
-            <a:noFill/>
-          </a:ln>
-          <a:effectLst/>
-        </p:spPr>
-        <p:style>
-          <a:lnRef idx="1">
-            <a:schemeClr val="accent1"/>
-          </a:lnRef>
-          <a:fillRef idx="3">
-            <a:schemeClr val="accent1"/>
-          </a:fillRef>
-          <a:effectRef idx="2">
-            <a:schemeClr val="accent1"/>
-          </a:effectRef>
-          <a:fontRef idx="minor">
-            <a:schemeClr val="lt1"/>
-          </a:fontRef>
-        </p:style>
-        <p:txBody>
-          <a:bodyPr rtlCol="0" anchor="ctr"/>
-          <a:lstStyle/>
-          <a:p>
-            <a:pPr algn="ctr"/>
-          </a:p>
-        </p:txBody>
-      </p:sp>
-      <p:sp>
-        <p:nvSpPr>
-          <p:cNvPr id="5" name="TextBox 4"/>
-          <p:cNvSpPr txBox="1"/>
-          <p:nvPr/>
-        </p:nvSpPr>
-        <p:spPr>
-          <a:xfrm>
-            <a:off x="365760" y="73152"/>
-            <a:ext cx="11247120" cy="411480"/>
-          </a:xfrm>
-          <a:prstGeom prst="rect">
-            <a:avLst/>
-          </a:prstGeom>
-          <a:noFill/>
-        </p:spPr>
-        <p:txBody>
-          <a:bodyPr wrap="square" anchor="t">
-            <a:spAutoFit/>
-          </a:bodyPr>
-          <a:lstStyle/>
-          <a:p>
-            <a:pPr algn="l"/>
-            <a:r>
-              <a:rPr sz="1300" b="1">
-                <a:solidFill>
-                  <a:srgbClr val="E7C14B"/>
-                </a:solidFill>
-                <a:latin typeface="Segoe UI"/>
-              </a:rPr>
-              <a:t>LA REGLA DE ORO</a:t>
-            </a:r>
-          </a:p>
-        </p:txBody>
-      </p:sp>
-      <p:sp>
-        <p:nvSpPr>
-          <p:cNvPr id="6" name="TextBox 5"/>
-          <p:cNvSpPr txBox="1"/>
-          <p:nvPr/>
-        </p:nvSpPr>
-        <p:spPr>
-          <a:xfrm>
-            <a:off x="365760" y="384048"/>
-            <a:ext cx="11064240" cy="914400"/>
-          </a:xfrm>
-          <a:prstGeom prst="rect">
-            <a:avLst/>
-          </a:prstGeom>
-          <a:noFill/>
-        </p:spPr>
-        <p:txBody>
-          <a:bodyPr wrap="square" anchor="t">
-            <a:spAutoFit/>
-          </a:bodyPr>
-          <a:lstStyle/>
-          <a:p>
-            <a:pPr algn="l"/>
-            <a:r>
-              <a:rPr sz="2600" b="1">
-                <a:solidFill>
-                  <a:srgbClr val="FFFFFF"/>
-                </a:solidFill>
-                <a:latin typeface="Segoe UI"/>
-              </a:rPr>
-              <a:t>Entrenar y evaluar</a:t>
-            </a:r>
-          </a:p>
-        </p:txBody>
-      </p:sp>
-      <p:sp>
-        <p:nvSpPr>
-          <p:cNvPr id="7" name="TextBox 6"/>
-          <p:cNvSpPr txBox="1"/>
-          <p:nvPr/>
-        </p:nvSpPr>
-        <p:spPr>
-          <a:xfrm>
-            <a:off x="502920" y="1691640"/>
-            <a:ext cx="11155680" cy="4572000"/>
-          </a:xfrm>
-          <a:prstGeom prst="rect">
-            <a:avLst/>
-          </a:prstGeom>
-          <a:noFill/>
-        </p:spPr>
-        <p:txBody>
-          <a:bodyPr wrap="square">
-            <a:spAutoFit/>
-          </a:bodyPr>
-          <a:lstStyle/>
-          <a:p>
-            <a:pPr>
-              <a:spcAft>
-                <a:spcPts val="1400"/>
-              </a:spcAft>
-            </a:pPr>
-            <a:r>
-              <a:rPr sz="1900">
-                <a:solidFill>
-                  <a:srgbClr val="1E1E32"/>
-                </a:solidFill>
-                <a:latin typeface="Segoe UI"/>
-              </a:rPr>
-              <a:t>•  Aprende con una parte de los datos y se evalúa con otra que nunca vio</a:t>
-            </a:r>
-          </a:p>
-          <a:p>
-            <a:pPr>
-              <a:spcAft>
-                <a:spcPts val="1400"/>
-              </a:spcAft>
-            </a:pPr>
-            <a:r>
-              <a:rPr sz="1900">
-                <a:solidFill>
-                  <a:srgbClr val="1E1E32"/>
-                </a:solidFill>
-                <a:latin typeface="Segoe UI"/>
-              </a:rPr>
-              <a:t>•  La validación cruzada estima el desempeño real</a:t>
-            </a:r>
-          </a:p>
-          <a:p>
-            <a:pPr>
-              <a:spcAft>
-                <a:spcPts val="1400"/>
-              </a:spcAft>
-            </a:pPr>
-            <a:r>
-              <a:rPr sz="1900">
-                <a:solidFill>
-                  <a:srgbClr val="1E1E32"/>
-                </a:solidFill>
-                <a:latin typeface="Segoe UI"/>
-              </a:rPr>
-              <a:t>•  El enemigo es el sobreajuste: perfecto en entrenamiento, falla con datos nuevos</a:t>
-            </a:r>
-          </a:p>
-        </p:txBody>
-      </p:sp>
-      <p:sp>
-        <p:nvSpPr>
-          <p:cNvPr id="8" name="Rectangle 7"/>
-          <p:cNvSpPr/>
-          <p:nvPr/>
-        </p:nvSpPr>
-        <p:spPr>
-          <a:xfrm>
-            <a:off x="0" y="6419088"/>
-            <a:ext cx="12191695" cy="438912"/>
-          </a:xfrm>
-          <a:prstGeom prst="rect">
-            <a:avLst/>
-          </a:prstGeom>
-          <a:solidFill>
-            <a:srgbClr val="962D37"/>
-          </a:solidFill>
-          <a:ln>
-            <a:noFill/>
-          </a:ln>
-          <a:effectLst/>
-        </p:spPr>
-        <p:style>
-          <a:lnRef idx="1">
-            <a:schemeClr val="accent1"/>
-          </a:lnRef>
-          <a:fillRef idx="3">
-            <a:schemeClr val="accent1"/>
-          </a:fillRef>
-          <a:effectRef idx="2">
-            <a:schemeClr val="accent1"/>
-          </a:effectRef>
-          <a:fontRef idx="minor">
-            <a:schemeClr val="lt1"/>
-          </a:fontRef>
-        </p:style>
-        <p:txBody>
-          <a:bodyPr rtlCol="0" anchor="ctr"/>
-          <a:lstStyle/>
-          <a:p>
-            <a:pPr algn="ctr"/>
-          </a:p>
-        </p:txBody>
-      </p:sp>
-      <p:sp>
-        <p:nvSpPr>
-          <p:cNvPr id="9" name="TextBox 8"/>
-          <p:cNvSpPr txBox="1"/>
-          <p:nvPr/>
-        </p:nvSpPr>
-        <p:spPr>
-          <a:xfrm>
-            <a:off x="566928" y="6473952"/>
-            <a:ext cx="11430000" cy="329184"/>
-          </a:xfrm>
-          <a:prstGeom prst="rect">
-            <a:avLst/>
-          </a:prstGeom>
-          <a:noFill/>
-        </p:spPr>
-        <p:txBody>
-          <a:bodyPr wrap="square" anchor="t">
-            <a:spAutoFit/>
-          </a:bodyPr>
-          <a:lstStyle/>
-          <a:p>
-            <a:pPr algn="l"/>
-            <a:r>
-              <a:rPr sz="1000" b="0">
-                <a:solidFill>
-                  <a:srgbClr val="FFFFFF"/>
-                </a:solidFill>
-                <a:latin typeface="Segoe UI"/>
-              </a:rPr>
-              <a:t>IA Aplicada a la Producción Pesquera   |   UTN FRCh   |   PesquerosEnIA   |   2026</a:t>
-            </a:r>
-          </a:p>
-        </p:txBody>
-      </p:sp>
       <p:pic>
         <p:nvPicPr>
-          <p:cNvPr id="10" name="Picture 9" descr="fishlogo.png"/>
+          <p:cNvPr id="2" name="Picture 1" descr="img_entrenar.png"/>
           <p:cNvPicPr>
             <a:picLocks noChangeAspect="1"/>
           </p:cNvPicPr>
@@ -4630,8 +3451,8 @@
         </p:blipFill>
         <p:spPr>
           <a:xfrm>
-            <a:off x="137160" y="6455664"/>
-            <a:ext cx="347472" cy="347472"/>
+            <a:off x="0" y="0"/>
+            <a:ext cx="12192000" cy="6858000"/>
           </a:xfrm>
           <a:prstGeom prst="rect">
             <a:avLst/>
@@ -4656,361 +3477,9 @@
         <p:nvPr/>
       </p:nvGrpSpPr>
       <p:grpSpPr/>
-      <p:sp>
-        <p:nvSpPr>
-          <p:cNvPr id="2" name="Rectangle 1"/>
-          <p:cNvSpPr/>
-          <p:nvPr/>
-        </p:nvSpPr>
-        <p:spPr>
-          <a:xfrm>
-            <a:off x="0" y="0"/>
-            <a:ext cx="12191695" cy="6858000"/>
-          </a:xfrm>
-          <a:prstGeom prst="rect">
-            <a:avLst/>
-          </a:prstGeom>
-          <a:solidFill>
-            <a:srgbClr val="F5F7FA"/>
-          </a:solidFill>
-          <a:ln>
-            <a:noFill/>
-          </a:ln>
-          <a:effectLst/>
-        </p:spPr>
-        <p:style>
-          <a:lnRef idx="1">
-            <a:schemeClr val="accent1"/>
-          </a:lnRef>
-          <a:fillRef idx="3">
-            <a:schemeClr val="accent1"/>
-          </a:fillRef>
-          <a:effectRef idx="2">
-            <a:schemeClr val="accent1"/>
-          </a:effectRef>
-          <a:fontRef idx="minor">
-            <a:schemeClr val="lt1"/>
-          </a:fontRef>
-        </p:style>
-        <p:txBody>
-          <a:bodyPr rtlCol="0" anchor="ctr"/>
-          <a:lstStyle/>
-          <a:p>
-            <a:pPr algn="ctr"/>
-          </a:p>
-        </p:txBody>
-      </p:sp>
-      <p:sp>
-        <p:nvSpPr>
-          <p:cNvPr id="3" name="Rectangle 2"/>
-          <p:cNvSpPr/>
-          <p:nvPr/>
-        </p:nvSpPr>
-        <p:spPr>
-          <a:xfrm>
-            <a:off x="0" y="0"/>
-            <a:ext cx="201168" cy="6858000"/>
-          </a:xfrm>
-          <a:prstGeom prst="rect">
-            <a:avLst/>
-          </a:prstGeom>
-          <a:solidFill>
-            <a:srgbClr val="962D37"/>
-          </a:solidFill>
-          <a:ln>
-            <a:noFill/>
-          </a:ln>
-          <a:effectLst/>
-        </p:spPr>
-        <p:style>
-          <a:lnRef idx="1">
-            <a:schemeClr val="accent1"/>
-          </a:lnRef>
-          <a:fillRef idx="3">
-            <a:schemeClr val="accent1"/>
-          </a:fillRef>
-          <a:effectRef idx="2">
-            <a:schemeClr val="accent1"/>
-          </a:effectRef>
-          <a:fontRef idx="minor">
-            <a:schemeClr val="lt1"/>
-          </a:fontRef>
-        </p:style>
-        <p:txBody>
-          <a:bodyPr rtlCol="0" anchor="ctr"/>
-          <a:lstStyle/>
-          <a:p>
-            <a:pPr algn="ctr"/>
-          </a:p>
-        </p:txBody>
-      </p:sp>
-      <p:sp>
-        <p:nvSpPr>
-          <p:cNvPr id="4" name="Rectangle 3"/>
-          <p:cNvSpPr/>
-          <p:nvPr/>
-        </p:nvSpPr>
-        <p:spPr>
-          <a:xfrm>
-            <a:off x="0" y="0"/>
-            <a:ext cx="12191695" cy="1371600"/>
-          </a:xfrm>
-          <a:prstGeom prst="rect">
-            <a:avLst/>
-          </a:prstGeom>
-          <a:solidFill>
-            <a:srgbClr val="962D37"/>
-          </a:solidFill>
-          <a:ln>
-            <a:noFill/>
-          </a:ln>
-          <a:effectLst/>
-        </p:spPr>
-        <p:style>
-          <a:lnRef idx="1">
-            <a:schemeClr val="accent1"/>
-          </a:lnRef>
-          <a:fillRef idx="3">
-            <a:schemeClr val="accent1"/>
-          </a:fillRef>
-          <a:effectRef idx="2">
-            <a:schemeClr val="accent1"/>
-          </a:effectRef>
-          <a:fontRef idx="minor">
-            <a:schemeClr val="lt1"/>
-          </a:fontRef>
-        </p:style>
-        <p:txBody>
-          <a:bodyPr rtlCol="0" anchor="ctr"/>
-          <a:lstStyle/>
-          <a:p>
-            <a:pPr algn="ctr"/>
-          </a:p>
-        </p:txBody>
-      </p:sp>
-      <p:sp>
-        <p:nvSpPr>
-          <p:cNvPr id="5" name="TextBox 4"/>
-          <p:cNvSpPr txBox="1"/>
-          <p:nvPr/>
-        </p:nvSpPr>
-        <p:spPr>
-          <a:xfrm>
-            <a:off x="365760" y="73152"/>
-            <a:ext cx="11247120" cy="411480"/>
-          </a:xfrm>
-          <a:prstGeom prst="rect">
-            <a:avLst/>
-          </a:prstGeom>
-          <a:noFill/>
-        </p:spPr>
-        <p:txBody>
-          <a:bodyPr wrap="square" anchor="t">
-            <a:spAutoFit/>
-          </a:bodyPr>
-          <a:lstStyle/>
-          <a:p>
-            <a:pPr algn="l"/>
-            <a:r>
-              <a:rPr sz="1300" b="1">
-                <a:solidFill>
-                  <a:srgbClr val="E7C14B"/>
-                </a:solidFill>
-                <a:latin typeface="Segoe UI"/>
-              </a:rPr>
-              <a:t>MEDIR CON HONESTIDAD</a:t>
-            </a:r>
-          </a:p>
-        </p:txBody>
-      </p:sp>
-      <p:sp>
-        <p:nvSpPr>
-          <p:cNvPr id="6" name="TextBox 5"/>
-          <p:cNvSpPr txBox="1"/>
-          <p:nvPr/>
-        </p:nvSpPr>
-        <p:spPr>
-          <a:xfrm>
-            <a:off x="365760" y="384048"/>
-            <a:ext cx="11064240" cy="914400"/>
-          </a:xfrm>
-          <a:prstGeom prst="rect">
-            <a:avLst/>
-          </a:prstGeom>
-          <a:noFill/>
-        </p:spPr>
-        <p:txBody>
-          <a:bodyPr wrap="square" anchor="t">
-            <a:spAutoFit/>
-          </a:bodyPr>
-          <a:lstStyle/>
-          <a:p>
-            <a:pPr algn="l"/>
-            <a:r>
-              <a:rPr sz="2600" b="1">
-                <a:solidFill>
-                  <a:srgbClr val="FFFFFF"/>
-                </a:solidFill>
-                <a:latin typeface="Segoe UI"/>
-              </a:rPr>
-              <a:t>Evaluar bien: ROC y errores</a:t>
-            </a:r>
-          </a:p>
-        </p:txBody>
-      </p:sp>
-      <p:sp>
-        <p:nvSpPr>
-          <p:cNvPr id="7" name="TextBox 6"/>
-          <p:cNvSpPr txBox="1"/>
-          <p:nvPr/>
-        </p:nvSpPr>
-        <p:spPr>
-          <a:xfrm>
-            <a:off x="502920" y="1691640"/>
-            <a:ext cx="11155680" cy="4572000"/>
-          </a:xfrm>
-          <a:prstGeom prst="rect">
-            <a:avLst/>
-          </a:prstGeom>
-          <a:noFill/>
-        </p:spPr>
-        <p:txBody>
-          <a:bodyPr wrap="square">
-            <a:spAutoFit/>
-          </a:bodyPr>
-          <a:lstStyle/>
-          <a:p>
-            <a:pPr>
-              <a:spcAft>
-                <a:spcPts val="1400"/>
-              </a:spcAft>
-            </a:pPr>
-            <a:r>
-              <a:rPr sz="1900">
-                <a:solidFill>
-                  <a:srgbClr val="1E1E32"/>
-                </a:solidFill>
-                <a:latin typeface="Segoe UI"/>
-              </a:rPr>
-              <a:t>•  La matriz de confusión y la curva ROC le ponen la nota al modelo</a:t>
-            </a:r>
-          </a:p>
-          <a:p>
-            <a:pPr>
-              <a:spcAft>
-                <a:spcPts val="1400"/>
-              </a:spcAft>
-            </a:pPr>
-            <a:r>
-              <a:rPr sz="1900">
-                <a:solidFill>
-                  <a:srgbClr val="1E1E32"/>
-                </a:solidFill>
-                <a:latin typeface="Segoe UI"/>
-              </a:rPr>
-              <a:t>•  Falso positivo: fuiste y no había. Falso negativo: te perdiste una buena</a:t>
-            </a:r>
-          </a:p>
-          <a:p>
-            <a:pPr>
-              <a:spcAft>
-                <a:spcPts val="1400"/>
-              </a:spcAft>
-            </a:pPr>
-            <a:r>
-              <a:rPr sz="1900">
-                <a:solidFill>
-                  <a:srgbClr val="1E1E32"/>
-                </a:solidFill>
-                <a:latin typeface="Segoe UI"/>
-              </a:rPr>
-              <a:t>•  Elegir el umbral es una decisión de negocio, no solo técnica</a:t>
-            </a:r>
-          </a:p>
-        </p:txBody>
-      </p:sp>
-      <p:sp>
-        <p:nvSpPr>
-          <p:cNvPr id="8" name="Rectangle 7"/>
-          <p:cNvSpPr/>
-          <p:nvPr/>
-        </p:nvSpPr>
-        <p:spPr>
-          <a:xfrm>
-            <a:off x="0" y="6419088"/>
-            <a:ext cx="12191695" cy="438912"/>
-          </a:xfrm>
-          <a:prstGeom prst="rect">
-            <a:avLst/>
-          </a:prstGeom>
-          <a:solidFill>
-            <a:srgbClr val="962D37"/>
-          </a:solidFill>
-          <a:ln>
-            <a:noFill/>
-          </a:ln>
-          <a:effectLst/>
-        </p:spPr>
-        <p:style>
-          <a:lnRef idx="1">
-            <a:schemeClr val="accent1"/>
-          </a:lnRef>
-          <a:fillRef idx="3">
-            <a:schemeClr val="accent1"/>
-          </a:fillRef>
-          <a:effectRef idx="2">
-            <a:schemeClr val="accent1"/>
-          </a:effectRef>
-          <a:fontRef idx="minor">
-            <a:schemeClr val="lt1"/>
-          </a:fontRef>
-        </p:style>
-        <p:txBody>
-          <a:bodyPr rtlCol="0" anchor="ctr"/>
-          <a:lstStyle/>
-          <a:p>
-            <a:pPr algn="ctr"/>
-          </a:p>
-        </p:txBody>
-      </p:sp>
-      <p:sp>
-        <p:nvSpPr>
-          <p:cNvPr id="9" name="TextBox 8"/>
-          <p:cNvSpPr txBox="1"/>
-          <p:nvPr/>
-        </p:nvSpPr>
-        <p:spPr>
-          <a:xfrm>
-            <a:off x="566928" y="6473952"/>
-            <a:ext cx="11430000" cy="329184"/>
-          </a:xfrm>
-          <a:prstGeom prst="rect">
-            <a:avLst/>
-          </a:prstGeom>
-          <a:noFill/>
-        </p:spPr>
-        <p:txBody>
-          <a:bodyPr wrap="square" anchor="t">
-            <a:spAutoFit/>
-          </a:bodyPr>
-          <a:lstStyle/>
-          <a:p>
-            <a:pPr algn="l"/>
-            <a:r>
-              <a:rPr sz="1000" b="0">
-                <a:solidFill>
-                  <a:srgbClr val="FFFFFF"/>
-                </a:solidFill>
-                <a:latin typeface="Segoe UI"/>
-              </a:rPr>
-              <a:t>IA Aplicada a la Producción Pesquera   |   UTN FRCh   |   PesquerosEnIA   |   2026</a:t>
-            </a:r>
-          </a:p>
-        </p:txBody>
-      </p:sp>
       <p:pic>
         <p:nvPicPr>
-          <p:cNvPr id="10" name="Picture 9" descr="fishlogo.png"/>
+          <p:cNvPr id="2" name="Picture 1" descr="reuse_zonas.png"/>
           <p:cNvPicPr>
             <a:picLocks noChangeAspect="1"/>
           </p:cNvPicPr>
@@ -5024,8 +3493,8 @@
         </p:blipFill>
         <p:spPr>
           <a:xfrm>
-            <a:off x="137160" y="6455664"/>
-            <a:ext cx="347472" cy="347472"/>
+            <a:off x="0" y="0"/>
+            <a:ext cx="12192000" cy="6858000"/>
           </a:xfrm>
           <a:prstGeom prst="rect">
             <a:avLst/>
@@ -5050,377 +3519,9 @@
         <p:nvPr/>
       </p:nvGrpSpPr>
       <p:grpSpPr/>
-      <p:sp>
-        <p:nvSpPr>
-          <p:cNvPr id="2" name="Rectangle 1"/>
-          <p:cNvSpPr/>
-          <p:nvPr/>
-        </p:nvSpPr>
-        <p:spPr>
-          <a:xfrm>
-            <a:off x="0" y="0"/>
-            <a:ext cx="12191695" cy="6858000"/>
-          </a:xfrm>
-          <a:prstGeom prst="rect">
-            <a:avLst/>
-          </a:prstGeom>
-          <a:solidFill>
-            <a:srgbClr val="F5F7FA"/>
-          </a:solidFill>
-          <a:ln>
-            <a:noFill/>
-          </a:ln>
-          <a:effectLst/>
-        </p:spPr>
-        <p:style>
-          <a:lnRef idx="1">
-            <a:schemeClr val="accent1"/>
-          </a:lnRef>
-          <a:fillRef idx="3">
-            <a:schemeClr val="accent1"/>
-          </a:fillRef>
-          <a:effectRef idx="2">
-            <a:schemeClr val="accent1"/>
-          </a:effectRef>
-          <a:fontRef idx="minor">
-            <a:schemeClr val="lt1"/>
-          </a:fontRef>
-        </p:style>
-        <p:txBody>
-          <a:bodyPr rtlCol="0" anchor="ctr"/>
-          <a:lstStyle/>
-          <a:p>
-            <a:pPr algn="ctr"/>
-          </a:p>
-        </p:txBody>
-      </p:sp>
-      <p:sp>
-        <p:nvSpPr>
-          <p:cNvPr id="3" name="Rectangle 2"/>
-          <p:cNvSpPr/>
-          <p:nvPr/>
-        </p:nvSpPr>
-        <p:spPr>
-          <a:xfrm>
-            <a:off x="0" y="0"/>
-            <a:ext cx="201168" cy="6858000"/>
-          </a:xfrm>
-          <a:prstGeom prst="rect">
-            <a:avLst/>
-          </a:prstGeom>
-          <a:solidFill>
-            <a:srgbClr val="962D37"/>
-          </a:solidFill>
-          <a:ln>
-            <a:noFill/>
-          </a:ln>
-          <a:effectLst/>
-        </p:spPr>
-        <p:style>
-          <a:lnRef idx="1">
-            <a:schemeClr val="accent1"/>
-          </a:lnRef>
-          <a:fillRef idx="3">
-            <a:schemeClr val="accent1"/>
-          </a:fillRef>
-          <a:effectRef idx="2">
-            <a:schemeClr val="accent1"/>
-          </a:effectRef>
-          <a:fontRef idx="minor">
-            <a:schemeClr val="lt1"/>
-          </a:fontRef>
-        </p:style>
-        <p:txBody>
-          <a:bodyPr rtlCol="0" anchor="ctr"/>
-          <a:lstStyle/>
-          <a:p>
-            <a:pPr algn="ctr"/>
-          </a:p>
-        </p:txBody>
-      </p:sp>
-      <p:sp>
-        <p:nvSpPr>
-          <p:cNvPr id="4" name="Rectangle 3"/>
-          <p:cNvSpPr/>
-          <p:nvPr/>
-        </p:nvSpPr>
-        <p:spPr>
-          <a:xfrm>
-            <a:off x="0" y="0"/>
-            <a:ext cx="12191695" cy="1371600"/>
-          </a:xfrm>
-          <a:prstGeom prst="rect">
-            <a:avLst/>
-          </a:prstGeom>
-          <a:solidFill>
-            <a:srgbClr val="962D37"/>
-          </a:solidFill>
-          <a:ln>
-            <a:noFill/>
-          </a:ln>
-          <a:effectLst/>
-        </p:spPr>
-        <p:style>
-          <a:lnRef idx="1">
-            <a:schemeClr val="accent1"/>
-          </a:lnRef>
-          <a:fillRef idx="3">
-            <a:schemeClr val="accent1"/>
-          </a:fillRef>
-          <a:effectRef idx="2">
-            <a:schemeClr val="accent1"/>
-          </a:effectRef>
-          <a:fontRef idx="minor">
-            <a:schemeClr val="lt1"/>
-          </a:fontRef>
-        </p:style>
-        <p:txBody>
-          <a:bodyPr rtlCol="0" anchor="ctr"/>
-          <a:lstStyle/>
-          <a:p>
-            <a:pPr algn="ctr"/>
-          </a:p>
-        </p:txBody>
-      </p:sp>
-      <p:sp>
-        <p:nvSpPr>
-          <p:cNvPr id="5" name="TextBox 4"/>
-          <p:cNvSpPr txBox="1"/>
-          <p:nvPr/>
-        </p:nvSpPr>
-        <p:spPr>
-          <a:xfrm>
-            <a:off x="365760" y="73152"/>
-            <a:ext cx="11247120" cy="411480"/>
-          </a:xfrm>
-          <a:prstGeom prst="rect">
-            <a:avLst/>
-          </a:prstGeom>
-          <a:noFill/>
-        </p:spPr>
-        <p:txBody>
-          <a:bodyPr wrap="square" anchor="t">
-            <a:spAutoFit/>
-          </a:bodyPr>
-          <a:lstStyle/>
-          <a:p>
-            <a:pPr algn="l"/>
-            <a:r>
-              <a:rPr sz="1300" b="1">
-                <a:solidFill>
-                  <a:srgbClr val="E7C14B"/>
-                </a:solidFill>
-                <a:latin typeface="Segoe UI"/>
-              </a:rPr>
-              <a:t>ABUNDANCIA Y RESPONSABILIDAD</a:t>
-            </a:r>
-          </a:p>
-        </p:txBody>
-      </p:sp>
-      <p:sp>
-        <p:nvSpPr>
-          <p:cNvPr id="6" name="TextBox 5"/>
-          <p:cNvSpPr txBox="1"/>
-          <p:nvPr/>
-        </p:nvSpPr>
-        <p:spPr>
-          <a:xfrm>
-            <a:off x="365760" y="384048"/>
-            <a:ext cx="11064240" cy="914400"/>
-          </a:xfrm>
-          <a:prstGeom prst="rect">
-            <a:avLst/>
-          </a:prstGeom>
-          <a:noFill/>
-        </p:spPr>
-        <p:txBody>
-          <a:bodyPr wrap="square" anchor="t">
-            <a:spAutoFit/>
-          </a:bodyPr>
-          <a:lstStyle/>
-          <a:p>
-            <a:pPr algn="l"/>
-            <a:r>
-              <a:rPr sz="2600" b="1">
-                <a:solidFill>
-                  <a:srgbClr val="FFFFFF"/>
-                </a:solidFill>
-                <a:latin typeface="Segoe UI"/>
-              </a:rPr>
-              <a:t>De "¿voy?" a "¿cuántos kg?" + ética</a:t>
-            </a:r>
-          </a:p>
-        </p:txBody>
-      </p:sp>
-      <p:sp>
-        <p:nvSpPr>
-          <p:cNvPr id="7" name="TextBox 6"/>
-          <p:cNvSpPr txBox="1"/>
-          <p:nvPr/>
-        </p:nvSpPr>
-        <p:spPr>
-          <a:xfrm>
-            <a:off x="502920" y="1691640"/>
-            <a:ext cx="11155680" cy="4572000"/>
-          </a:xfrm>
-          <a:prstGeom prst="rect">
-            <a:avLst/>
-          </a:prstGeom>
-          <a:noFill/>
-        </p:spPr>
-        <p:txBody>
-          <a:bodyPr wrap="square">
-            <a:spAutoFit/>
-          </a:bodyPr>
-          <a:lstStyle/>
-          <a:p>
-            <a:pPr>
-              <a:spcAft>
-                <a:spcPts val="1400"/>
-              </a:spcAft>
-            </a:pPr>
-            <a:r>
-              <a:rPr sz="1900">
-                <a:solidFill>
-                  <a:srgbClr val="1E1E32"/>
-                </a:solidFill>
-                <a:latin typeface="Segoe UI"/>
-              </a:rPr>
-              <a:t>•  Clasificación (sí/no) vs. regresión (cantidad · abundancia)</a:t>
-            </a:r>
-          </a:p>
-          <a:p>
-            <a:pPr>
-              <a:spcAft>
-                <a:spcPts val="1400"/>
-              </a:spcAft>
-            </a:pPr>
-            <a:r>
-              <a:rPr sz="1900">
-                <a:solidFill>
-                  <a:srgbClr val="1E1E32"/>
-                </a:solidFill>
-                <a:latin typeface="Segoe UI"/>
-              </a:rPr>
-              <a:t>•  El modelo revela qué variables mandan: SST y clorofila</a:t>
-            </a:r>
-          </a:p>
-          <a:p>
-            <a:pPr>
-              <a:spcAft>
-                <a:spcPts val="1400"/>
-              </a:spcAft>
-            </a:pPr>
-            <a:r>
-              <a:rPr sz="1900">
-                <a:solidFill>
-                  <a:srgbClr val="1E1E32"/>
-                </a:solidFill>
-                <a:latin typeface="Segoe UI"/>
-              </a:rPr>
-              <a:t>•  Aprende del pasado y sus sesgos → validar con datos independientes</a:t>
-            </a:r>
-          </a:p>
-          <a:p>
-            <a:pPr>
-              <a:spcAft>
-                <a:spcPts val="1400"/>
-              </a:spcAft>
-            </a:pPr>
-            <a:r>
-              <a:rPr sz="1900">
-                <a:solidFill>
-                  <a:srgbClr val="1E1E32"/>
-                </a:solidFill>
-                <a:latin typeface="Segoe UI"/>
-              </a:rPr>
-              <a:t>•  Nunca para pescar fuera de cuota o en veda. La IA asiste; no reemplaza</a:t>
-            </a:r>
-          </a:p>
-        </p:txBody>
-      </p:sp>
-      <p:sp>
-        <p:nvSpPr>
-          <p:cNvPr id="8" name="Rectangle 7"/>
-          <p:cNvSpPr/>
-          <p:nvPr/>
-        </p:nvSpPr>
-        <p:spPr>
-          <a:xfrm>
-            <a:off x="0" y="6419088"/>
-            <a:ext cx="12191695" cy="438912"/>
-          </a:xfrm>
-          <a:prstGeom prst="rect">
-            <a:avLst/>
-          </a:prstGeom>
-          <a:solidFill>
-            <a:srgbClr val="962D37"/>
-          </a:solidFill>
-          <a:ln>
-            <a:noFill/>
-          </a:ln>
-          <a:effectLst/>
-        </p:spPr>
-        <p:style>
-          <a:lnRef idx="1">
-            <a:schemeClr val="accent1"/>
-          </a:lnRef>
-          <a:fillRef idx="3">
-            <a:schemeClr val="accent1"/>
-          </a:fillRef>
-          <a:effectRef idx="2">
-            <a:schemeClr val="accent1"/>
-          </a:effectRef>
-          <a:fontRef idx="minor">
-            <a:schemeClr val="lt1"/>
-          </a:fontRef>
-        </p:style>
-        <p:txBody>
-          <a:bodyPr rtlCol="0" anchor="ctr"/>
-          <a:lstStyle/>
-          <a:p>
-            <a:pPr algn="ctr"/>
-          </a:p>
-        </p:txBody>
-      </p:sp>
-      <p:sp>
-        <p:nvSpPr>
-          <p:cNvPr id="9" name="TextBox 8"/>
-          <p:cNvSpPr txBox="1"/>
-          <p:nvPr/>
-        </p:nvSpPr>
-        <p:spPr>
-          <a:xfrm>
-            <a:off x="566928" y="6473952"/>
-            <a:ext cx="11430000" cy="329184"/>
-          </a:xfrm>
-          <a:prstGeom prst="rect">
-            <a:avLst/>
-          </a:prstGeom>
-          <a:noFill/>
-        </p:spPr>
-        <p:txBody>
-          <a:bodyPr wrap="square" anchor="t">
-            <a:spAutoFit/>
-          </a:bodyPr>
-          <a:lstStyle/>
-          <a:p>
-            <a:pPr algn="l"/>
-            <a:r>
-              <a:rPr sz="1000" b="0">
-                <a:solidFill>
-                  <a:srgbClr val="FFFFFF"/>
-                </a:solidFill>
-                <a:latin typeface="Segoe UI"/>
-              </a:rPr>
-              <a:t>IA Aplicada a la Producción Pesquera   |   UTN FRCh   |   PesquerosEnIA   |   2026</a:t>
-            </a:r>
-          </a:p>
-        </p:txBody>
-      </p:sp>
       <p:pic>
         <p:nvPicPr>
-          <p:cNvPr id="10" name="Picture 9" descr="fishlogo.png"/>
+          <p:cNvPr id="2" name="Picture 1" descr="reuse_errores.png"/>
           <p:cNvPicPr>
             <a:picLocks noChangeAspect="1"/>
           </p:cNvPicPr>
@@ -5434,8 +3535,8 @@
         </p:blipFill>
         <p:spPr>
           <a:xfrm>
-            <a:off x="137160" y="6455664"/>
-            <a:ext cx="347472" cy="347472"/>
+            <a:off x="0" y="0"/>
+            <a:ext cx="12192000" cy="6858000"/>
           </a:xfrm>
           <a:prstGeom prst="rect">
             <a:avLst/>
@@ -5460,120 +3561,30 @@
         <p:nvPr/>
       </p:nvGrpSpPr>
       <p:grpSpPr/>
-      <p:sp>
-        <p:nvSpPr>
-          <p:cNvPr id="2" name="Rectangle 1"/>
-          <p:cNvSpPr/>
+      <p:pic>
+        <p:nvPicPr>
+          <p:cNvPr id="2" name="Picture 1" descr="img_voy.png"/>
+          <p:cNvPicPr>
+            <a:picLocks noChangeAspect="1"/>
+          </p:cNvPicPr>
           <p:nvPr/>
-        </p:nvSpPr>
+        </p:nvPicPr>
+        <p:blipFill>
+          <a:blip r:embed="rId2"/>
+          <a:stretch>
+            <a:fillRect/>
+          </a:stretch>
+        </p:blipFill>
         <p:spPr>
           <a:xfrm>
             <a:off x="0" y="0"/>
-            <a:ext cx="12191695" cy="6858000"/>
+            <a:ext cx="12192000" cy="6858000"/>
           </a:xfrm>
           <a:prstGeom prst="rect">
             <a:avLst/>
           </a:prstGeom>
-          <a:solidFill>
-            <a:srgbClr val="962D37"/>
-          </a:solidFill>
-          <a:ln>
-            <a:noFill/>
-          </a:ln>
-          <a:effectLst/>
         </p:spPr>
-        <p:style>
-          <a:lnRef idx="1">
-            <a:schemeClr val="accent1"/>
-          </a:lnRef>
-          <a:fillRef idx="3">
-            <a:schemeClr val="accent1"/>
-          </a:fillRef>
-          <a:effectRef idx="2">
-            <a:schemeClr val="accent1"/>
-          </a:effectRef>
-          <a:fontRef idx="minor">
-            <a:schemeClr val="lt1"/>
-          </a:fontRef>
-        </p:style>
-        <p:txBody>
-          <a:bodyPr rtlCol="0" anchor="ctr"/>
-          <a:lstStyle/>
-          <a:p>
-            <a:pPr algn="ctr"/>
-          </a:p>
-        </p:txBody>
-      </p:sp>
-      <p:sp>
-        <p:nvSpPr>
-          <p:cNvPr id="3" name="TextBox 2"/>
-          <p:cNvSpPr txBox="1"/>
-          <p:nvPr/>
-        </p:nvSpPr>
-        <p:spPr>
-          <a:xfrm>
-            <a:off x="914400" y="2468880"/>
-            <a:ext cx="10332720" cy="1463040"/>
-          </a:xfrm>
-          <a:prstGeom prst="rect">
-            <a:avLst/>
-          </a:prstGeom>
-          <a:noFill/>
-        </p:spPr>
-        <p:txBody>
-          <a:bodyPr wrap="square" anchor="ctr">
-            <a:spAutoFit/>
-          </a:bodyPr>
-          <a:lstStyle/>
-          <a:p>
-            <a:pPr algn="ctr"/>
-            <a:r>
-              <a:rPr sz="3800" b="1">
-                <a:solidFill>
-                  <a:srgbClr val="FFFFFF"/>
-                </a:solidFill>
-                <a:latin typeface="Segoe UI"/>
-              </a:rPr>
-              <a:t>La IA asiste al capitán; no lo reemplaza</a:t>
-            </a:r>
-          </a:p>
-        </p:txBody>
-      </p:sp>
-      <p:sp>
-        <p:nvSpPr>
-          <p:cNvPr id="4" name="TextBox 3"/>
-          <p:cNvSpPr txBox="1"/>
-          <p:nvPr/>
-        </p:nvSpPr>
-        <p:spPr>
-          <a:xfrm>
-            <a:off x="1371600" y="4114800"/>
-            <a:ext cx="9418320" cy="914400"/>
-          </a:xfrm>
-          <a:prstGeom prst="rect">
-            <a:avLst/>
-          </a:prstGeom>
-          <a:noFill/>
-        </p:spPr>
-        <p:txBody>
-          <a:bodyPr wrap="square" anchor="t">
-            <a:spAutoFit/>
-          </a:bodyPr>
-          <a:lstStyle/>
-          <a:p>
-            <a:pPr algn="ctr"/>
-            <a:r>
-              <a:rPr sz="2000" b="0">
-                <a:solidFill>
-                  <a:srgbClr val="DDE9F0"/>
-                </a:solidFill>
-                <a:latin typeface="Segoe UI"/>
-              </a:rPr>
-              <a:t>La sostenibilidad no es un límite: es la brújula</a:t>
-            </a:r>
-          </a:p>
-        </p:txBody>
-      </p:sp>
+      </p:pic>
     </p:spTree>
   </p:cSld>
   <p:clrMapOvr>
@@ -5594,7 +3605,7 @@
       <p:grpSpPr/>
       <p:pic>
         <p:nvPicPr>
-          <p:cNvPr id="2" name="Picture 1" descr="c6_1.png"/>
+          <p:cNvPr id="2" name="Picture 1" descr="reuse_stocks.png"/>
           <p:cNvPicPr>
             <a:picLocks noChangeAspect="1"/>
           </p:cNvPicPr>
@@ -5609,7 +3620,7 @@
         <p:spPr>
           <a:xfrm>
             <a:off x="0" y="0"/>
-            <a:ext cx="12191695" cy="6858000"/>
+            <a:ext cx="12192000" cy="6858000"/>
           </a:xfrm>
           <a:prstGeom prst="rect">
             <a:avLst/>
@@ -5636,7 +3647,7 @@
       <p:grpSpPr/>
       <p:pic>
         <p:nvPicPr>
-          <p:cNvPr id="2" name="Picture 1" descr="c6_2.png"/>
+          <p:cNvPr id="2" name="Picture 1" descr="reuse_tendencia.png"/>
           <p:cNvPicPr>
             <a:picLocks noChangeAspect="1"/>
           </p:cNvPicPr>
@@ -5651,7 +3662,7 @@
         <p:spPr>
           <a:xfrm>
             <a:off x="0" y="0"/>
-            <a:ext cx="12191695" cy="6858000"/>
+            <a:ext cx="12192000" cy="6858000"/>
           </a:xfrm>
           <a:prstGeom prst="rect">
             <a:avLst/>

</xml_diff>